<commit_message>
docs: updated Round 2 deck (998 tests, G13 gate row, claims aligned with the README)
Claude-Session: https://claude.ai/code/session_01QXwf3GSkk849J2aZsEBb4p
</commit_message>
<xml_diff>
--- a/VITVellore_AICA.pptx
+++ b/VITVellore_AICA.pptx
@@ -10642,7 +10642,7 @@
         </p:nvSpPr>
         <p:spPr>
           <a:xfrm>
-            <a:off x="2804219" y="5348240"/>
+            <a:off x="3413819" y="5410051"/>
             <a:ext cx="2433711" cy="171450"/>
           </a:xfrm>
           <a:prstGeom prst="rect">
@@ -10694,7 +10694,7 @@
         </p:nvSpPr>
         <p:spPr>
           <a:xfrm>
-            <a:off x="2804219" y="5597845"/>
+            <a:off x="3413819" y="5571443"/>
             <a:ext cx="2042219" cy="492443"/>
           </a:xfrm>
           <a:prstGeom prst="rect">
@@ -10931,7 +10931,7 @@
         <p:spPr>
           <a:xfrm>
             <a:off x="9138046" y="5581501"/>
-            <a:ext cx="2387203" cy="777240"/>
+            <a:ext cx="2387203" cy="492443"/>
           </a:xfrm>
           <a:prstGeom prst="rect">
             <a:avLst/>
@@ -10963,7 +10963,12 @@
               </a:defRPr>
             </a:pPr>
             <a:r>
-              <a:t>779 Tests</a:t>
+              <a:rPr lang="en-US" dirty="0"/>
+              <a:t>998</a:t>
+            </a:r>
+            <a:r>
+              <a:rPr dirty="0"/>
+              <a:t> Tests</a:t>
             </a:r>
             <a:endParaRPr dirty="0">
               <a:solidFill>
@@ -10981,8 +10986,14 @@
               </a:defRPr>
             </a:pPr>
             <a:r>
-              <a:t>Stepped-clock replayable</a:t>
-            </a:r>
+              <a:rPr dirty="0"/>
+              <a:t>Stepped-clock </a:t>
+            </a:r>
+            <a:r>
+              <a:rPr dirty="0" err="1"/>
+              <a:t>replayable</a:t>
+            </a:r>
+            <a:endParaRPr dirty="0"/>
           </a:p>
         </p:txBody>
       </p:sp>
@@ -11029,6 +11040,100 @@
               <a:rPr lang="en-IN" dirty="0"/>
               <a:t>Built for the Samsung Language AI team</a:t>
             </a:r>
+          </a:p>
+        </p:txBody>
+      </p:sp>
+      <p:sp>
+        <p:nvSpPr>
+          <p:cNvPr id="2" name="TextBox 1">
+            <a:extLst>
+              <a:ext uri="{FF2B5EF4-FFF2-40B4-BE49-F238E27FC236}">
+                <a16:creationId xmlns:a16="http://schemas.microsoft.com/office/drawing/2014/main" id="{9AF796F9-52C7-3FAD-5D8C-F107E52DA8C9}"/>
+              </a:ext>
+            </a:extLst>
+          </p:cNvPr>
+          <p:cNvSpPr txBox="1"/>
+          <p:nvPr/>
+        </p:nvSpPr>
+        <p:spPr>
+          <a:xfrm>
+            <a:off x="468019" y="5294144"/>
+            <a:ext cx="2945800" cy="954107"/>
+          </a:xfrm>
+          <a:prstGeom prst="rect">
+            <a:avLst/>
+          </a:prstGeom>
+          <a:noFill/>
+        </p:spPr>
+        <p:txBody>
+          <a:bodyPr wrap="square" rtlCol="0">
+            <a:spAutoFit/>
+          </a:bodyPr>
+          <a:lstStyle/>
+          <a:p>
+            <a:r>
+              <a:rPr lang="en-US" dirty="0">
+                <a:latin typeface="Times New Roman" panose="02020603050405020304" pitchFamily="18" charset="0"/>
+                <a:cs typeface="Times New Roman" panose="02020603050405020304" pitchFamily="18" charset="0"/>
+              </a:rPr>
+              <a:t>Aditya Santhosh P</a:t>
+            </a:r>
+          </a:p>
+          <a:p>
+            <a:r>
+              <a:rPr lang="en-US" dirty="0">
+                <a:latin typeface="Times New Roman" panose="02020603050405020304" pitchFamily="18" charset="0"/>
+                <a:cs typeface="Times New Roman" panose="02020603050405020304" pitchFamily="18" charset="0"/>
+              </a:rPr>
+              <a:t>Eldo John </a:t>
+            </a:r>
+            <a:r>
+              <a:rPr lang="en-US" dirty="0" err="1">
+                <a:latin typeface="Times New Roman" panose="02020603050405020304" pitchFamily="18" charset="0"/>
+                <a:cs typeface="Times New Roman" panose="02020603050405020304" pitchFamily="18" charset="0"/>
+              </a:rPr>
+              <a:t>Giby</a:t>
+            </a:r>
+            <a:endParaRPr lang="en-US" dirty="0">
+              <a:latin typeface="Times New Roman" panose="02020603050405020304" pitchFamily="18" charset="0"/>
+              <a:cs typeface="Times New Roman" panose="02020603050405020304" pitchFamily="18" charset="0"/>
+            </a:endParaRPr>
+          </a:p>
+          <a:p>
+            <a:r>
+              <a:rPr lang="en-US" dirty="0">
+                <a:latin typeface="Times New Roman" panose="02020603050405020304" pitchFamily="18" charset="0"/>
+                <a:cs typeface="Times New Roman" panose="02020603050405020304" pitchFamily="18" charset="0"/>
+              </a:rPr>
+              <a:t>V </a:t>
+            </a:r>
+            <a:r>
+              <a:rPr lang="en-US" dirty="0" err="1">
+                <a:latin typeface="Times New Roman" panose="02020603050405020304" pitchFamily="18" charset="0"/>
+                <a:cs typeface="Times New Roman" panose="02020603050405020304" pitchFamily="18" charset="0"/>
+              </a:rPr>
+              <a:t>V</a:t>
+            </a:r>
+            <a:r>
+              <a:rPr lang="en-US" dirty="0">
+                <a:latin typeface="Times New Roman" panose="02020603050405020304" pitchFamily="18" charset="0"/>
+                <a:cs typeface="Times New Roman" panose="02020603050405020304" pitchFamily="18" charset="0"/>
+              </a:rPr>
+              <a:t> Ramarathinam Iyer</a:t>
+            </a:r>
+          </a:p>
+          <a:p>
+            <a:r>
+              <a:rPr lang="en-US" dirty="0">
+                <a:latin typeface="Times New Roman" panose="02020603050405020304" pitchFamily="18" charset="0"/>
+                <a:cs typeface="Times New Roman" panose="02020603050405020304" pitchFamily="18" charset="0"/>
+              </a:rPr>
+              <a:t>Aryaman Tripathi</a:t>
+            </a:r>
+            <a:endParaRPr lang="en-IN" dirty="0">
+              <a:latin typeface="Times New Roman" panose="02020603050405020304" pitchFamily="18" charset="0"/>
+              <a:cs typeface="Times New Roman" panose="02020603050405020304" pitchFamily="18" charset="0"/>
+            </a:endParaRPr>
           </a:p>
         </p:txBody>
       </p:sp>
@@ -11185,7 +11290,7 @@
         <p:spPr>
           <a:xfrm>
             <a:off x="505968" y="1238890"/>
-            <a:ext cx="10997184" cy="4093428"/>
+            <a:ext cx="10997184" cy="3170099"/>
           </a:xfrm>
           <a:prstGeom prst="rect">
             <a:avLst/>
@@ -11286,42 +11391,7 @@
             </a:r>
           </a:p>
           <a:p>
-            <a:pPr lvl="0" algn="just"/>
-            <a:endParaRPr lang="en-IN" sz="2000" dirty="0">
-              <a:latin typeface="Calibri" panose="020F0502020204030204" pitchFamily="34" charset="0"/>
-              <a:ea typeface="Calibri" panose="020F0502020204030204" pitchFamily="34" charset="0"/>
-              <a:cs typeface="Calibri" panose="020F0502020204030204" pitchFamily="34" charset="0"/>
-            </a:endParaRPr>
-          </a:p>
-          <a:p>
             <a:pPr algn="just"/>
-            <a:r>
-              <a:rPr lang="en-IN" sz="2000" dirty="0">
-                <a:latin typeface="Calibri" panose="020F0502020204030204" pitchFamily="34" charset="0"/>
-                <a:ea typeface="Calibri" panose="020F0502020204030204" pitchFamily="34" charset="0"/>
-                <a:cs typeface="Calibri" panose="020F0502020204030204" pitchFamily="34" charset="0"/>
-              </a:rPr>
-              <a:t>A single standard 32-core cloud node can coordinate over </a:t>
-            </a:r>
-            <a:r>
-              <a:rPr lang="en-IN" sz="2000" b="1" dirty="0">
-                <a:latin typeface="Calibri" panose="020F0502020204030204" pitchFamily="34" charset="0"/>
-                <a:ea typeface="Calibri" panose="020F0502020204030204" pitchFamily="34" charset="0"/>
-                <a:cs typeface="Calibri" panose="020F0502020204030204" pitchFamily="34" charset="0"/>
-              </a:rPr>
-              <a:t>5,000 concurrent active calls</a:t>
-            </a:r>
-            <a:r>
-              <a:rPr lang="en-IN" sz="2000" dirty="0">
-                <a:latin typeface="Calibri" panose="020F0502020204030204" pitchFamily="34" charset="0"/>
-                <a:ea typeface="Calibri" panose="020F0502020204030204" pitchFamily="34" charset="0"/>
-                <a:cs typeface="Calibri" panose="020F0502020204030204" pitchFamily="34" charset="0"/>
-              </a:rPr>
-              <a:t> without CPU thread starvation.</a:t>
-            </a:r>
-          </a:p>
-          <a:p>
-            <a:pPr lvl="0" algn="just"/>
             <a:endParaRPr lang="en-IN" sz="2000" dirty="0">
               <a:latin typeface="Calibri" panose="020F0502020204030204" pitchFamily="34" charset="0"/>
               <a:ea typeface="Calibri" panose="020F0502020204030204" pitchFamily="34" charset="0"/>
@@ -11670,7 +11740,7 @@
         <p:spPr>
           <a:xfrm>
             <a:off x="505968" y="1238890"/>
-            <a:ext cx="5586984" cy="1169551"/>
+            <a:ext cx="5586984" cy="1000274"/>
           </a:xfrm>
           <a:prstGeom prst="rect">
             <a:avLst/>
@@ -11700,7 +11770,7 @@
             <a:pPr lvl="0" algn="just"/>
             <a:r>
               <a:rPr lang="en-IN" sz="1100" dirty="0"/>
-              <a:t>Built directly against official Samsung SmartThings Developer REST APIs with zero mocks or synthetic shims.</a:t>
+              <a:t>Built directly against official Samsung SmartThings Developer REST APIs.</a:t>
             </a:r>
           </a:p>
           <a:p>
@@ -11945,7 +12015,7 @@
             <a:pPr lvl="0" algn="just"/>
             <a:r>
               <a:rPr lang="en-IN" sz="1200" dirty="0"/>
-              <a:t>Semantic fingerprinting and plan lineage tracking mathematically guarantee that no command is ever sent twice over the radio network.</a:t>
+              <a:t>Semantic fingerprinting and plan lineage tracking ensure that no command is ever sent twice over the radio network.</a:t>
             </a:r>
             <a:endParaRPr lang="en-IN" sz="1200" dirty="0">
               <a:effectLst/>
@@ -12272,7 +12342,7 @@
         <p:spPr>
           <a:xfrm>
             <a:off x="685800" y="1463040"/>
-            <a:ext cx="6035040" cy="4297680"/>
+            <a:ext cx="6035040" cy="3600986"/>
           </a:xfrm>
           <a:prstGeom prst="rect">
             <a:avLst/>
@@ -12286,82 +12356,106 @@
           <a:lstStyle/>
           <a:p>
             <a:r>
-              <a:rPr sz="1500" b="1"/>
+              <a:rPr sz="1500" b="1" dirty="0"/>
               <a:t>DEMO WALKTHROUGH TIMELINE (&lt; 2 MINS)</a:t>
             </a:r>
           </a:p>
           <a:p>
-            <a:endParaRPr sz="1500" b="1"/>
-          </a:p>
-          <a:p>
-            <a:r>
-              <a:rPr sz="1300" b="1"/>
-              <a:t>0:00 – 0:10 | Companion App Joins Room</a:t>
-            </a:r>
-          </a:p>
-          <a:p>
-            <a:r>
-              <a:rPr sz="1200" b="0"/>
+            <a:endParaRPr sz="1500" b="1" dirty="0"/>
+          </a:p>
+          <a:p>
+            <a:r>
+              <a:rPr sz="1300" b="1" dirty="0"/>
+              <a:t>Companion App Joins Room</a:t>
+            </a:r>
+          </a:p>
+          <a:p>
+            <a:r>
+              <a:rPr sz="1200" b="0" dirty="0"/>
               <a:t>Live device tiles appear (Lock, Garage, AC, Switch, Washer) over WebRTC.</a:t>
             </a:r>
           </a:p>
           <a:p>
-            <a:endParaRPr sz="1200" b="0"/>
-          </a:p>
-          <a:p>
-            <a:r>
-              <a:rPr sz="1300" b="1"/>
-              <a:t>0:10 – 0:40 | Washer Error (4C) Diagnostics</a:t>
-            </a:r>
-          </a:p>
-          <a:p>
-            <a:r>
-              <a:rPr sz="1200" b="0"/>
+            <a:endParaRPr lang="en-US" sz="1300" b="1" dirty="0"/>
+          </a:p>
+          <a:p>
+            <a:r>
+              <a:rPr sz="1300" b="1" dirty="0"/>
+              <a:t>Washer Error (4C) Diagnostics</a:t>
+            </a:r>
+          </a:p>
+          <a:p>
+            <a:r>
+              <a:rPr sz="1200" b="0" dirty="0"/>
               <a:t>Camera reads 7-segment display. Agent diagnoses water supply error and speaks fix.</a:t>
             </a:r>
           </a:p>
           <a:p>
-            <a:endParaRPr sz="1200" b="0"/>
-          </a:p>
-          <a:p>
-            <a:r>
-              <a:rPr sz="1300" b="1"/>
-              <a:t>0:40 – 1:10 | Mid-Speech Correction &amp; G12 Security Gate</a:t>
-            </a:r>
-          </a:p>
-          <a:p>
-            <a:r>
-              <a:rPr sz="1200" b="0"/>
-              <a:t>"Set AC to 24... no, 26" — 24 is cancelled before emit. "Lock door" triggers spoken confirmation.</a:t>
-            </a:r>
-          </a:p>
-          <a:p>
-            <a:endParaRPr sz="1200" b="0"/>
-          </a:p>
-          <a:p>
-            <a:r>
-              <a:rPr sz="1300" b="1"/>
-              <a:t>1:10 – 1:35 | Live Failure Drill ("Sent is Not Done")</a:t>
-            </a:r>
-          </a:p>
-          <a:p>
-            <a:r>
-              <a:rPr sz="1200" b="0"/>
+            <a:endParaRPr sz="1200" b="0" dirty="0"/>
+          </a:p>
+          <a:p>
+            <a:r>
+              <a:rPr sz="1300" b="1" dirty="0"/>
+              <a:t>Mid-Speech Correction &amp; G12 Security Gate</a:t>
+            </a:r>
+          </a:p>
+          <a:p>
+            <a:r>
+              <a:rPr sz="1200" b="0" dirty="0"/>
+              <a:t>"Set AC to 2</a:t>
+            </a:r>
+            <a:r>
+              <a:rPr lang="en-US" sz="1200" b="0" dirty="0"/>
+              <a:t>2</a:t>
+            </a:r>
+            <a:r>
+              <a:rPr sz="1200" b="0" dirty="0"/>
+              <a:t>... no, 2</a:t>
+            </a:r>
+            <a:r>
+              <a:rPr lang="en-US" sz="1200" b="0" dirty="0"/>
+              <a:t>1</a:t>
+            </a:r>
+            <a:r>
+              <a:rPr sz="1200" b="0" dirty="0"/>
+              <a:t>" — 2</a:t>
+            </a:r>
+            <a:r>
+              <a:rPr lang="en-US" sz="1200" b="0" dirty="0"/>
+              <a:t>2</a:t>
+            </a:r>
+            <a:r>
+              <a:rPr sz="1200" b="0" dirty="0"/>
+              <a:t> is cancelled before emit. "Lock door" triggers spoken confirmation.</a:t>
+            </a:r>
+          </a:p>
+          <a:p>
+            <a:endParaRPr sz="1200" b="0" dirty="0"/>
+          </a:p>
+          <a:p>
+            <a:r>
+              <a:rPr sz="1300" b="1" dirty="0"/>
+              <a:t>Live Failure Drill ("Sent is Not Done")</a:t>
+            </a:r>
+          </a:p>
+          <a:p>
+            <a:r>
+              <a:rPr sz="1200" b="0" dirty="0"/>
               <a:t>Jury injects stuck lock. State never confirms. Agent speaks: "Sent, but couldn't confirm."</a:t>
             </a:r>
           </a:p>
           <a:p>
-            <a:endParaRPr sz="1200" b="0"/>
-          </a:p>
-          <a:p>
-            <a:r>
-              <a:rPr sz="1300" b="1"/>
-              <a:t>1:35 – 1:50 | Effect Ledger Summary</a:t>
-            </a:r>
-          </a:p>
-          <a:p>
-            <a:r>
-              <a:rPr sz="1200" b="0"/>
+            <a:endParaRPr sz="1200" b="0" dirty="0"/>
+          </a:p>
+          <a:p>
+            <a:r>
+              <a:rPr sz="1300" b="1" dirty="0"/>
+              <a:t>Effect Ledger Summary</a:t>
+            </a:r>
+          </a:p>
+          <a:p>
+            <a:r>
+              <a:rPr sz="1200" b="0" dirty="0"/>
               <a:t>App displays: 2 committed, 1 cancelled before send, 1 unconfirmed, 0 duplicates.</a:t>
             </a:r>
           </a:p>
@@ -12945,7 +13039,7 @@
         <p:spPr>
           <a:xfrm>
             <a:off x="609600" y="2043112"/>
-            <a:ext cx="3232100" cy="1000125"/>
+            <a:ext cx="3232100" cy="830997"/>
           </a:xfrm>
           <a:prstGeom prst="rect">
             <a:avLst/>
@@ -12960,13 +13054,49 @@
           <a:p>
             <a:pPr algn="l"/>
             <a:r>
-              <a:rPr sz="1350" b="0" i="0" u="none">
+              <a:rPr sz="1350" b="0" i="0" u="none" dirty="0">
                 <a:solidFill>
                   <a:srgbClr val="334155"/>
                 </a:solidFill>
                 <a:latin typeface="Inter"/>
               </a:rPr>
-              <a:t>GPU edge host: Silero VAD, single-writer kernel, Kokoro TTS. Phone: LiveKit audio &amp; companion display. Cloud: Gemini 3.6 Flash / GPT-4.1 for reasoning depth.</a:t>
+              <a:t>GPU edge host: </a:t>
+            </a:r>
+            <a:r>
+              <a:rPr sz="1350" b="0" i="0" u="none" dirty="0" err="1">
+                <a:solidFill>
+                  <a:srgbClr val="334155"/>
+                </a:solidFill>
+                <a:latin typeface="Inter"/>
+              </a:rPr>
+              <a:t>Silero</a:t>
+            </a:r>
+            <a:r>
+              <a:rPr sz="1350" b="0" i="0" u="none" dirty="0">
+                <a:solidFill>
+                  <a:srgbClr val="334155"/>
+                </a:solidFill>
+                <a:latin typeface="Inter"/>
+              </a:rPr>
+              <a:t> VAD, single-writer kernel, Kokoro TTS. Phone: </a:t>
+            </a:r>
+            <a:r>
+              <a:rPr sz="1350" b="0" i="0" u="none" dirty="0" err="1">
+                <a:solidFill>
+                  <a:srgbClr val="334155"/>
+                </a:solidFill>
+                <a:latin typeface="Inter"/>
+              </a:rPr>
+              <a:t>LiveKit</a:t>
+            </a:r>
+            <a:r>
+              <a:rPr sz="1350" b="0" i="0" u="none" dirty="0">
+                <a:solidFill>
+                  <a:srgbClr val="334155"/>
+                </a:solidFill>
+                <a:latin typeface="Inter"/>
+              </a:rPr>
+              <a:t> audio &amp; companion display. Cloud: Gemini 3.6 Flash for reasoning depth.</a:t>
             </a:r>
           </a:p>
         </p:txBody>
@@ -15118,7 +15248,7 @@
         <p:spPr>
           <a:xfrm>
             <a:off x="822960" y="2286000"/>
-            <a:ext cx="1764792" cy="2011680"/>
+            <a:ext cx="1764792" cy="1343958"/>
           </a:xfrm>
           <a:prstGeom prst="rect">
             <a:avLst/>
@@ -15150,25 +15280,41 @@
               </a:defRPr>
             </a:pPr>
             <a:r>
-              <a:rPr sz="1200" b="0"/>
-              <a:t>• Silero VAD (1.5s floor)</a:t>
-            </a:r>
-          </a:p>
-          <a:p>
-            <a:r>
-              <a:rPr sz="1200" b="0"/>
+              <a:rPr sz="1200" b="0" dirty="0"/>
+              <a:t>• </a:t>
+            </a:r>
+            <a:r>
+              <a:rPr sz="1200" b="0" dirty="0" err="1"/>
+              <a:t>Silero</a:t>
+            </a:r>
+            <a:r>
+              <a:rPr sz="1200" b="0" dirty="0"/>
+              <a:t> VAD (</a:t>
+            </a:r>
+            <a:r>
+              <a:rPr lang="en-US" sz="1200" b="0" dirty="0"/>
+              <a:t>0</a:t>
+            </a:r>
+            <a:r>
+              <a:rPr sz="1200" b="0" dirty="0"/>
+              <a:t>.5s floor)</a:t>
+            </a:r>
+          </a:p>
+          <a:p>
+            <a:r>
+              <a:rPr sz="1200" b="0" dirty="0"/>
               <a:t>• Fast STT (OpenAI / Whisper)</a:t>
             </a:r>
           </a:p>
           <a:p>
             <a:r>
-              <a:rPr sz="1200" b="0"/>
+              <a:rPr sz="1200" b="0" dirty="0"/>
               <a:t>• 1 fps camera frame buffer</a:t>
             </a:r>
           </a:p>
           <a:p>
             <a:r>
-              <a:rPr sz="1200" b="0"/>
+              <a:rPr sz="1200" b="0" dirty="0"/>
               <a:t>• Streamed transcript events</a:t>
             </a:r>
           </a:p>
@@ -17416,12 +17562,83 @@
           <a:chExt cx="0" cy="0"/>
         </a:xfrm>
       </p:grpSpPr>
+      <p:sp>
+        <p:nvSpPr>
+          <p:cNvPr id="4" name="Google Shape;249;p22">
+            <a:extLst>
+              <a:ext uri="{FF2B5EF4-FFF2-40B4-BE49-F238E27FC236}">
+                <a16:creationId xmlns:a16="http://schemas.microsoft.com/office/drawing/2014/main" id="{9E4A9C9C-EC25-2FBE-AA62-A4623BDD3E01}"/>
+              </a:ext>
+            </a:extLst>
+          </p:cNvPr>
+          <p:cNvSpPr txBox="1"/>
+          <p:nvPr/>
+        </p:nvSpPr>
+        <p:spPr>
+          <a:xfrm>
+            <a:off x="685800" y="365760"/>
+            <a:ext cx="10789920" cy="777240"/>
+          </a:xfrm>
+          <a:prstGeom prst="rect">
+            <a:avLst/>
+          </a:prstGeom>
+          <a:noFill/>
+          <a:ln>
+            <a:noFill/>
+          </a:ln>
+        </p:spPr>
+        <p:txBody>
+          <a:bodyPr spcFirstLastPara="1" wrap="square" lIns="0" tIns="0" rIns="0" bIns="0" anchor="t" anchorCtr="0">
+            <a:spAutoFit/>
+          </a:bodyPr>
+          <a:lstStyle/>
+          <a:p>
+            <a:pPr marL="0" marR="0" lvl="0" indent="0" algn="l" rtl="0">
+              <a:spcBef>
+                <a:spcPts val="0"/>
+              </a:spcBef>
+              <a:spcAft>
+                <a:spcPts val="200"/>
+              </a:spcAft>
+              <a:buNone/>
+              <a:defRPr sz="1100" b="1">
+                <a:solidFill>
+                  <a:srgbClr val="2B4C3F"/>
+                </a:solidFill>
+                <a:latin typeface="Calibri"/>
+              </a:defRPr>
+            </a:pPr>
+            <a:r>
+              <a:rPr dirty="0"/>
+              <a:t>2. CORE ARCHITECTURE &amp; ADMISSION SAFETY</a:t>
+            </a:r>
+          </a:p>
+          <a:p>
+            <a:pPr>
+              <a:defRPr sz="2400" b="1">
+                <a:solidFill>
+                  <a:srgbClr val="1F2326"/>
+                </a:solidFill>
+                <a:latin typeface="Calibri"/>
+              </a:defRPr>
+            </a:pPr>
+            <a:r>
+              <a:rPr dirty="0" err="1"/>
+              <a:t>CommitGate</a:t>
+            </a:r>
+            <a:r>
+              <a:rPr dirty="0"/>
+              <a:t> (G1-G12) &amp; Pre-Emission Effect Ledger</a:t>
+            </a:r>
+          </a:p>
+        </p:txBody>
+      </p:sp>
       <p:pic>
         <p:nvPicPr>
-          <p:cNvPr id="5" name="Picture 4">
+          <p:cNvPr id="8" name="Picture 7">
             <a:extLst>
               <a:ext uri="{FF2B5EF4-FFF2-40B4-BE49-F238E27FC236}">
-                <a16:creationId xmlns:a16="http://schemas.microsoft.com/office/drawing/2014/main" id="{AA28CCC3-CD71-ACCD-C977-3F6DACCDFDB1}"/>
+                <a16:creationId xmlns:a16="http://schemas.microsoft.com/office/drawing/2014/main" id="{4A4C2056-C0BC-A8D3-CA7F-3A5CAEB681C9}"/>
               </a:ext>
             </a:extLst>
           </p:cNvPr>
@@ -17438,8 +17655,8 @@
         </p:blipFill>
         <p:spPr>
           <a:xfrm>
-            <a:off x="288758" y="1045623"/>
-            <a:ext cx="7459579" cy="5419767"/>
+            <a:off x="685800" y="1036282"/>
+            <a:ext cx="4696051" cy="5732308"/>
           </a:xfrm>
           <a:prstGeom prst="rect">
             <a:avLst/>
@@ -17448,10 +17665,10 @@
       </p:pic>
       <p:pic>
         <p:nvPicPr>
-          <p:cNvPr id="7" name="Picture 6">
+          <p:cNvPr id="10" name="Picture 9">
             <a:extLst>
               <a:ext uri="{FF2B5EF4-FFF2-40B4-BE49-F238E27FC236}">
-                <a16:creationId xmlns:a16="http://schemas.microsoft.com/office/drawing/2014/main" id="{11BF7953-9D37-8FCB-CCFA-1BD78609F48A}"/>
+                <a16:creationId xmlns:a16="http://schemas.microsoft.com/office/drawing/2014/main" id="{16A0D7BA-5145-F3AD-E5A2-8506C3729D77}"/>
               </a:ext>
             </a:extLst>
           </p:cNvPr>
@@ -17468,85 +17685,14 @@
         </p:blipFill>
         <p:spPr>
           <a:xfrm>
-            <a:off x="9601200" y="1234440"/>
-            <a:ext cx="1417320" cy="4846320"/>
+            <a:off x="8477420" y="490301"/>
+            <a:ext cx="1962424" cy="5582429"/>
           </a:xfrm>
           <a:prstGeom prst="rect">
             <a:avLst/>
           </a:prstGeom>
         </p:spPr>
       </p:pic>
-      <p:sp>
-        <p:nvSpPr>
-          <p:cNvPr id="4" name="Google Shape;249;p22">
-            <a:extLst>
-              <a:ext uri="{FF2B5EF4-FFF2-40B4-BE49-F238E27FC236}">
-                <a16:creationId xmlns:a16="http://schemas.microsoft.com/office/drawing/2014/main" id="{9E4A9C9C-EC25-2FBE-AA62-A4623BDD3E01}"/>
-              </a:ext>
-            </a:extLst>
-          </p:cNvPr>
-          <p:cNvSpPr txBox="1"/>
-          <p:nvPr/>
-        </p:nvSpPr>
-        <p:spPr>
-          <a:xfrm>
-            <a:off x="685800" y="365760"/>
-            <a:ext cx="10789920" cy="777240"/>
-          </a:xfrm>
-          <a:prstGeom prst="rect">
-            <a:avLst/>
-          </a:prstGeom>
-          <a:noFill/>
-          <a:ln>
-            <a:noFill/>
-          </a:ln>
-        </p:spPr>
-        <p:txBody>
-          <a:bodyPr spcFirstLastPara="1" wrap="square" lIns="0" tIns="0" rIns="0" bIns="0" anchor="t" anchorCtr="0">
-            <a:spAutoFit/>
-          </a:bodyPr>
-          <a:lstStyle/>
-          <a:p>
-            <a:pPr marL="0" marR="0" lvl="0" indent="0" algn="l" rtl="0">
-              <a:spcBef>
-                <a:spcPts val="0"/>
-              </a:spcBef>
-              <a:spcAft>
-                <a:spcPts val="200"/>
-              </a:spcAft>
-              <a:buNone/>
-              <a:defRPr sz="1100" b="1">
-                <a:solidFill>
-                  <a:srgbClr val="2B4C3F"/>
-                </a:solidFill>
-                <a:latin typeface="Calibri"/>
-              </a:defRPr>
-            </a:pPr>
-            <a:r>
-              <a:rPr dirty="0"/>
-              <a:t>2. CORE ARCHITECTURE &amp; ADMISSION SAFETY</a:t>
-            </a:r>
-          </a:p>
-          <a:p>
-            <a:pPr>
-              <a:defRPr sz="2400" b="1">
-                <a:solidFill>
-                  <a:srgbClr val="1F2326"/>
-                </a:solidFill>
-                <a:latin typeface="Calibri"/>
-              </a:defRPr>
-            </a:pPr>
-            <a:r>
-              <a:rPr dirty="0" err="1"/>
-              <a:t>CommitGate</a:t>
-            </a:r>
-            <a:r>
-              <a:rPr dirty="0"/>
-              <a:t> (G1-G12) &amp; Pre-Emission Effect Ledger</a:t>
-            </a:r>
-          </a:p>
-        </p:txBody>
-      </p:sp>
     </p:spTree>
     <p:extLst>
       <p:ext uri="{BB962C8B-B14F-4D97-AF65-F5344CB8AC3E}">
@@ -17631,78 +17777,21 @@
           </a:p>
         </p:txBody>
       </p:sp>
-      <p:sp>
-        <p:nvSpPr>
-          <p:cNvPr id="246" name="Google Shape;246;p22"/>
-          <p:cNvSpPr/>
-          <p:nvPr/>
-        </p:nvSpPr>
-        <p:spPr>
-          <a:xfrm>
-            <a:off x="685800" y="2176462"/>
-            <a:ext cx="10820400" cy="2676525"/>
-          </a:xfrm>
-          <a:prstGeom prst="roundRect">
-            <a:avLst>
-              <a:gd name="adj" fmla="val 0"/>
-            </a:avLst>
-          </a:prstGeom>
-          <a:solidFill>
-            <a:srgbClr val="F4F3EF"/>
-          </a:solidFill>
-          <a:ln w="9525" cap="flat" cmpd="sng">
-            <a:solidFill>
-              <a:srgbClr val="4A7DBA"/>
-            </a:solidFill>
-            <a:prstDash val="solid"/>
-            <a:round/>
-            <a:headEnd type="none" w="sm" len="sm"/>
-            <a:tailEnd type="none" w="sm" len="sm"/>
-          </a:ln>
-          <a:effectLst>
-            <a:outerShdw blurRad="40000" dist="23000" dir="5400000" rotWithShape="0">
-              <a:srgbClr val="000000">
-                <a:alpha val="34902"/>
-              </a:srgbClr>
-            </a:outerShdw>
-          </a:effectLst>
-        </p:spPr>
-        <p:txBody>
-          <a:bodyPr spcFirstLastPara="1" wrap="square" lIns="91425" tIns="45700" rIns="91425" bIns="45700" anchor="ctr" anchorCtr="0">
-            <a:noAutofit/>
-          </a:bodyPr>
-          <a:lstStyle/>
-          <a:p>
-            <a:pPr marL="0" marR="0" lvl="0" indent="0" algn="ctr" rtl="0">
-              <a:spcBef>
-                <a:spcPts val="0"/>
-              </a:spcBef>
-              <a:spcAft>
-                <a:spcPts val="0"/>
-              </a:spcAft>
-              <a:buNone/>
-            </a:pPr>
-            <a:endParaRPr sz="1800" b="0" i="0" u="none" strike="noStrike" cap="none">
-              <a:solidFill>
-                <a:schemeClr val="dk1"/>
-              </a:solidFill>
-              <a:latin typeface="Calibri"/>
-              <a:ea typeface="Calibri"/>
-              <a:cs typeface="Calibri"/>
-              <a:sym typeface="Calibri"/>
-            </a:endParaRPr>
-          </a:p>
-        </p:txBody>
-      </p:sp>
       <p:graphicFrame>
         <p:nvGraphicFramePr>
           <p:cNvPr id="247" name="Google Shape;247;p22"/>
           <p:cNvGraphicFramePr/>
-          <p:nvPr/>
+          <p:nvPr>
+            <p:extLst>
+              <p:ext uri="{D42A27DB-BD31-4B8C-83A1-F6EECF244321}">
+                <p14:modId xmlns:p14="http://schemas.microsoft.com/office/powerpoint/2010/main" val="3194772173"/>
+              </p:ext>
+            </p:extLst>
+          </p:nvPr>
         </p:nvGraphicFramePr>
         <p:xfrm>
-          <a:off x="685800" y="2176462"/>
-          <a:ext cx="10810875" cy="2692655"/>
+          <a:off x="685800" y="1402553"/>
+          <a:ext cx="10810875" cy="3154935"/>
         </p:xfrm>
         <a:graphic>
           <a:graphicData uri="http://schemas.openxmlformats.org/drawingml/2006/table">
@@ -17756,7 +17845,7 @@
                         </a:defRPr>
                       </a:pPr>
                       <a:r>
-                        <a:rPr lang="en-US" sz="1200" b="1" i="0" u="none" strike="noStrike" cap="none">
+                        <a:rPr lang="en-US" sz="1200" b="1" i="0" u="none" strike="noStrike" cap="none" dirty="0">
                           <a:solidFill>
                             <a:srgbClr val="FFFFFF"/>
                           </a:solidFill>
@@ -17767,7 +17856,7 @@
                         </a:rPr>
                         <a:t>Gate</a:t>
                       </a:r>
-                      <a:endParaRPr/>
+                      <a:endParaRPr dirty="0"/>
                     </a:p>
                   </a:txBody>
                   <a:tcPr marL="63500" marR="63500" marT="25400" marB="25400" anchor="ctr">
@@ -17841,7 +17930,7 @@
                         </a:defRPr>
                       </a:pPr>
                       <a:r>
-                        <a:rPr lang="en-US" sz="1200" b="1" i="0" u="none" strike="noStrike" cap="none">
+                        <a:rPr lang="en-US" sz="1200" b="1" i="0" u="none" strike="noStrike" cap="none" dirty="0">
                           <a:solidFill>
                             <a:srgbClr val="FFFFFF"/>
                           </a:solidFill>
@@ -17852,7 +17941,7 @@
                         </a:rPr>
                         <a:t>Admission Rule Enforced</a:t>
                       </a:r>
-                      <a:endParaRPr/>
+                      <a:endParaRPr dirty="0"/>
                     </a:p>
                   </a:txBody>
                   <a:tcPr marL="63500" marR="63500" marT="25400" marB="25400" anchor="ctr">
@@ -18105,7 +18194,7 @@
                       <a:r>
                         <a:rPr lang="en-US" sz="1350" b="0" i="0" u="none" strike="noStrike" cap="none">
                           <a:solidFill>
-                            <a:srgbClr val="1F2326"/>
+                            <a:schemeClr val="tx1"/>
                           </a:solidFill>
                           <a:latin typeface="Calibri"/>
                           <a:ea typeface="Calibri"/>
@@ -18114,7 +18203,11 @@
                         </a:rPr>
                         <a:t>Tool exists/usable (G1) and read set is still valid (G2)</a:t>
                       </a:r>
-                      <a:endParaRPr/>
+                      <a:endParaRPr>
+                        <a:solidFill>
+                          <a:schemeClr val="tx1"/>
+                        </a:solidFill>
+                      </a:endParaRPr>
                     </a:p>
                   </a:txBody>
                   <a:tcPr marL="63500" marR="63500" marT="25400" marB="25400" anchor="ctr">
@@ -18190,7 +18283,7 @@
                       <a:r>
                         <a:rPr lang="en-US" sz="1350" b="0" i="0" u="none" strike="noStrike" cap="none">
                           <a:solidFill>
-                            <a:srgbClr val="3E444A"/>
+                            <a:schemeClr val="tx1"/>
                           </a:solidFill>
                           <a:latin typeface="Calibri"/>
                           <a:ea typeface="Calibri"/>
@@ -18199,7 +18292,11 @@
                         </a:rPr>
                         <a:t>Fail goal honestly or cancel stale call</a:t>
                       </a:r>
-                      <a:endParaRPr/>
+                      <a:endParaRPr>
+                        <a:solidFill>
+                          <a:schemeClr val="tx1"/>
+                        </a:solidFill>
+                      </a:endParaRPr>
                     </a:p>
                   </a:txBody>
                   <a:tcPr marL="63500" marR="63500" marT="25400" marB="25400" anchor="ctr">
@@ -18280,7 +18377,7 @@
                         </a:defRPr>
                       </a:pPr>
                       <a:r>
-                        <a:rPr lang="en-US" sz="1350" b="1" i="0" u="none" strike="noStrike" cap="none">
+                        <a:rPr lang="en-US" sz="1350" b="1" i="0" u="none" strike="noStrike" cap="none" dirty="0">
                           <a:solidFill>
                             <a:srgbClr val="2B4C3F"/>
                           </a:solidFill>
@@ -18291,7 +18388,7 @@
                         </a:rPr>
                         <a:t>G3 – G4</a:t>
                       </a:r>
-                      <a:endParaRPr/>
+                      <a:endParaRPr dirty="0"/>
                     </a:p>
                   </a:txBody>
                   <a:tcPr marL="63500" marR="63500" marT="25400" marB="25400" anchor="ctr">
@@ -18367,7 +18464,7 @@
                       <a:r>
                         <a:rPr lang="en-US" sz="1350" b="0" i="0" u="none" strike="noStrike" cap="none">
                           <a:solidFill>
-                            <a:srgbClr val="1F2326"/>
+                            <a:schemeClr val="tx1"/>
                           </a:solidFill>
                           <a:latin typeface="Calibri"/>
                           <a:ea typeface="Calibri"/>
@@ -18376,7 +18473,11 @@
                         </a:rPr>
                         <a:t>Floor closed/user quiet (G3) &amp; explicit user go-ahead (G4)</a:t>
                       </a:r>
-                      <a:endParaRPr/>
+                      <a:endParaRPr>
+                        <a:solidFill>
+                          <a:schemeClr val="tx1"/>
+                        </a:solidFill>
+                      </a:endParaRPr>
                     </a:p>
                   </a:txBody>
                   <a:tcPr marL="63500" marR="63500" marT="25400" marB="25400" anchor="ctr">
@@ -18452,7 +18553,7 @@
                       <a:r>
                         <a:rPr lang="en-US" sz="1350" b="0" i="0" u="none" strike="noStrike" cap="none">
                           <a:solidFill>
-                            <a:srgbClr val="3E444A"/>
+                            <a:schemeClr val="tx1"/>
                           </a:solidFill>
                           <a:latin typeface="Calibri"/>
                           <a:ea typeface="Calibri"/>
@@ -18461,7 +18562,11 @@
                         </a:rPr>
                         <a:t>Hold call or ask "Shall I go ahead...?"</a:t>
                       </a:r>
-                      <a:endParaRPr/>
+                      <a:endParaRPr>
+                        <a:solidFill>
+                          <a:schemeClr val="tx1"/>
+                        </a:solidFill>
+                      </a:endParaRPr>
                     </a:p>
                   </a:txBody>
                   <a:tcPr marL="63500" marR="63500" marT="25400" marB="25400" anchor="ctr">
@@ -18629,7 +18734,7 @@
                       <a:r>
                         <a:rPr lang="en-US" sz="1350" b="0" i="0" u="none" strike="noStrike" cap="none">
                           <a:solidFill>
-                            <a:srgbClr val="1F2326"/>
+                            <a:schemeClr val="tx1"/>
                           </a:solidFill>
                           <a:latin typeface="Calibri"/>
                           <a:ea typeface="Calibri"/>
@@ -18638,7 +18743,11 @@
                         </a:rPr>
                         <a:t>No duplicate fingerprint (G5) or plan-step lineage effect (G6)</a:t>
                       </a:r>
-                      <a:endParaRPr/>
+                      <a:endParaRPr>
+                        <a:solidFill>
+                          <a:schemeClr val="tx1"/>
+                        </a:solidFill>
+                      </a:endParaRPr>
                     </a:p>
                   </a:txBody>
                   <a:tcPr marL="63500" marR="63500" marT="25400" marB="25400" anchor="ctr">
@@ -18714,7 +18823,7 @@
                       <a:r>
                         <a:rPr lang="en-US" sz="1350" b="0" i="0" u="none" strike="noStrike" cap="none">
                           <a:solidFill>
-                            <a:srgbClr val="3E444A"/>
+                            <a:schemeClr val="tx1"/>
                           </a:solidFill>
                           <a:latin typeface="Calibri"/>
                           <a:ea typeface="Calibri"/>
@@ -18723,7 +18832,11 @@
                         </a:rPr>
                         <a:t>Block write; report what already ran</a:t>
                       </a:r>
-                      <a:endParaRPr/>
+                      <a:endParaRPr>
+                        <a:solidFill>
+                          <a:schemeClr val="tx1"/>
+                        </a:solidFill>
+                      </a:endParaRPr>
                     </a:p>
                   </a:txBody>
                   <a:tcPr marL="63500" marR="63500" marT="25400" marB="25400" anchor="ctr">
@@ -18804,7 +18917,7 @@
                         </a:defRPr>
                       </a:pPr>
                       <a:r>
-                        <a:rPr lang="en-US" sz="1350" b="1" i="0" u="none" strike="noStrike" cap="none">
+                        <a:rPr lang="en-US" sz="1350" b="1" i="0" u="none" strike="noStrike" cap="none" dirty="0">
                           <a:solidFill>
                             <a:srgbClr val="2B4C3F"/>
                           </a:solidFill>
@@ -18815,7 +18928,7 @@
                         </a:rPr>
                         <a:t>G7 – G8</a:t>
                       </a:r>
-                      <a:endParaRPr/>
+                      <a:endParaRPr dirty="0"/>
                     </a:p>
                   </a:txBody>
                   <a:tcPr marL="63500" marR="63500" marT="25400" marB="25400" anchor="ctr">
@@ -18891,7 +19004,7 @@
                       <a:r>
                         <a:rPr lang="en-US" sz="1350" b="0" i="0" u="none" strike="noStrike" cap="none" dirty="0">
                           <a:solidFill>
-                            <a:srgbClr val="1F2326"/>
+                            <a:schemeClr val="tx1"/>
                           </a:solidFill>
                           <a:latin typeface="Calibri"/>
                           <a:ea typeface="Calibri"/>
@@ -18903,7 +19016,7 @@
                       <a:r>
                         <a:rPr lang="en-US" sz="1350" b="0" i="0" u="none" strike="noStrike" cap="none" dirty="0" err="1">
                           <a:solidFill>
-                            <a:srgbClr val="1F2326"/>
+                            <a:schemeClr val="tx1"/>
                           </a:solidFill>
                           <a:latin typeface="Calibri"/>
                           <a:ea typeface="Calibri"/>
@@ -18915,7 +19028,7 @@
                       <a:r>
                         <a:rPr lang="en-US" sz="1350" b="0" i="0" u="none" strike="noStrike" cap="none" dirty="0">
                           <a:solidFill>
-                            <a:srgbClr val="1F2326"/>
+                            <a:schemeClr val="tx1"/>
                           </a:solidFill>
                           <a:latin typeface="Calibri"/>
                           <a:ea typeface="Calibri"/>
@@ -18924,7 +19037,11 @@
                         </a:rPr>
                         <a:t> (G8)</a:t>
                       </a:r>
-                      <a:endParaRPr dirty="0"/>
+                      <a:endParaRPr dirty="0">
+                        <a:solidFill>
+                          <a:schemeClr val="tx1"/>
+                        </a:solidFill>
+                      </a:endParaRPr>
                     </a:p>
                   </a:txBody>
                   <a:tcPr marL="63500" marR="63500" marT="25400" marB="25400" anchor="ctr">
@@ -19000,7 +19117,7 @@
                       <a:r>
                         <a:rPr lang="en-US" sz="1350" b="0" i="0" u="none" strike="noStrike" cap="none">
                           <a:solidFill>
-                            <a:srgbClr val="3E444A"/>
+                            <a:schemeClr val="tx1"/>
                           </a:solidFill>
                           <a:latin typeface="Calibri"/>
                           <a:ea typeface="Calibri"/>
@@ -19009,7 +19126,11 @@
                         </a:rPr>
                         <a:t>Ask user before retry; refuse blank args</a:t>
                       </a:r>
-                      <a:endParaRPr/>
+                      <a:endParaRPr>
+                        <a:solidFill>
+                          <a:schemeClr val="tx1"/>
+                        </a:solidFill>
+                      </a:endParaRPr>
                     </a:p>
                   </a:txBody>
                   <a:tcPr marL="63500" marR="63500" marT="25400" marB="25400" anchor="ctr">
@@ -19138,7 +19259,7 @@
                       <a:headEnd type="none" w="sm" len="sm"/>
                       <a:tailEnd type="none" w="sm" len="sm"/>
                     </a:lnT>
-                    <a:lnB w="9525" cap="flat" cmpd="sng">
+                    <a:lnB w="9525" cap="flat" cmpd="sng" algn="ctr">
                       <a:solidFill>
                         <a:srgbClr val="000000">
                           <a:alpha val="0"/>
@@ -19177,7 +19298,7 @@
                       <a:r>
                         <a:rPr lang="en-US" sz="1350" b="0" i="0" u="none" strike="noStrike" cap="none" dirty="0">
                           <a:solidFill>
-                            <a:srgbClr val="1F2326"/>
+                            <a:schemeClr val="tx1"/>
                           </a:solidFill>
                           <a:latin typeface="Calibri"/>
                           <a:ea typeface="Calibri"/>
@@ -19186,7 +19307,11 @@
                         </a:rPr>
                         <a:t>Valid at emission (G9), settle window (G10), no open turn (G11), explicit user confirmation for security actions (G12)</a:t>
                       </a:r>
-                      <a:endParaRPr dirty="0"/>
+                      <a:endParaRPr dirty="0">
+                        <a:solidFill>
+                          <a:schemeClr val="tx1"/>
+                        </a:solidFill>
+                      </a:endParaRPr>
                     </a:p>
                   </a:txBody>
                   <a:tcPr marL="63500" marR="63500" marT="25400" marB="25400" anchor="ctr">
@@ -19202,6 +19327,179 @@
                       <a:tailEnd type="none" w="sm" len="sm"/>
                     </a:lnL>
                     <a:lnR w="9525" cap="flat" cmpd="sng">
+                      <a:solidFill>
+                        <a:srgbClr val="000000">
+                          <a:alpha val="0"/>
+                        </a:srgbClr>
+                      </a:solidFill>
+                      <a:prstDash val="solid"/>
+                      <a:round/>
+                      <a:headEnd type="none" w="sm" len="sm"/>
+                      <a:tailEnd type="none" w="sm" len="sm"/>
+                    </a:lnR>
+                    <a:lnT w="9525" cap="flat" cmpd="sng">
+                      <a:solidFill>
+                        <a:srgbClr val="000000">
+                          <a:alpha val="0"/>
+                        </a:srgbClr>
+                      </a:solidFill>
+                      <a:prstDash val="solid"/>
+                      <a:round/>
+                      <a:headEnd type="none" w="sm" len="sm"/>
+                      <a:tailEnd type="none" w="sm" len="sm"/>
+                    </a:lnT>
+                    <a:lnB w="9525" cap="flat" cmpd="sng" algn="ctr">
+                      <a:solidFill>
+                        <a:srgbClr val="000000">
+                          <a:alpha val="0"/>
+                        </a:srgbClr>
+                      </a:solidFill>
+                      <a:prstDash val="solid"/>
+                      <a:round/>
+                      <a:headEnd type="none" w="sm" len="sm"/>
+                      <a:tailEnd type="none" w="sm" len="sm"/>
+                    </a:lnB>
+                    <a:solidFill>
+                      <a:srgbClr val="F4F3EF"/>
+                    </a:solidFill>
+                  </a:tcPr>
+                </a:tc>
+                <a:tc>
+                  <a:txBody>
+                    <a:bodyPr/>
+                    <a:lstStyle/>
+                    <a:p>
+                      <a:pPr marL="0" marR="0" lvl="0" indent="0" algn="l" rtl="0">
+                        <a:spcBef>
+                          <a:spcPts val="0"/>
+                        </a:spcBef>
+                        <a:spcAft>
+                          <a:spcPts val="0"/>
+                        </a:spcAft>
+                        <a:buNone/>
+                        <a:defRPr sz="1000">
+                          <a:solidFill>
+                            <a:srgbClr val="3E444A"/>
+                          </a:solidFill>
+                          <a:latin typeface="Calibri"/>
+                        </a:defRPr>
+                      </a:pPr>
+                      <a:r>
+                        <a:rPr lang="en-US" sz="1350" b="0" i="0" u="none" strike="noStrike" cap="none" dirty="0">
+                          <a:solidFill>
+                            <a:schemeClr val="tx1"/>
+                          </a:solidFill>
+                          <a:latin typeface="Calibri"/>
+                          <a:ea typeface="Calibri"/>
+                          <a:cs typeface="Calibri"/>
+                          <a:sym typeface="Calibri"/>
+                        </a:rPr>
+                        <a:t>Withdraw before wire or hold for correction</a:t>
+                      </a:r>
+                      <a:endParaRPr dirty="0">
+                        <a:solidFill>
+                          <a:schemeClr val="tx1"/>
+                        </a:solidFill>
+                      </a:endParaRPr>
+                    </a:p>
+                  </a:txBody>
+                  <a:tcPr marL="63500" marR="63500" marT="25400" marB="25400" anchor="ctr">
+                    <a:lnL w="9525" cap="flat" cmpd="sng">
+                      <a:solidFill>
+                        <a:srgbClr val="000000">
+                          <a:alpha val="0"/>
+                        </a:srgbClr>
+                      </a:solidFill>
+                      <a:prstDash val="solid"/>
+                      <a:round/>
+                      <a:headEnd type="none" w="sm" len="sm"/>
+                      <a:tailEnd type="none" w="sm" len="sm"/>
+                    </a:lnL>
+                    <a:lnR w="9525" cap="flat" cmpd="sng">
+                      <a:solidFill>
+                        <a:srgbClr val="000000">
+                          <a:alpha val="0"/>
+                        </a:srgbClr>
+                      </a:solidFill>
+                      <a:prstDash val="solid"/>
+                      <a:round/>
+                      <a:headEnd type="none" w="sm" len="sm"/>
+                      <a:tailEnd type="none" w="sm" len="sm"/>
+                    </a:lnR>
+                    <a:lnT w="9525" cap="flat" cmpd="sng">
+                      <a:solidFill>
+                        <a:srgbClr val="000000">
+                          <a:alpha val="0"/>
+                        </a:srgbClr>
+                      </a:solidFill>
+                      <a:prstDash val="solid"/>
+                      <a:round/>
+                      <a:headEnd type="none" w="sm" len="sm"/>
+                      <a:tailEnd type="none" w="sm" len="sm"/>
+                    </a:lnT>
+                    <a:lnB w="9525" cap="flat" cmpd="sng" algn="ctr">
+                      <a:solidFill>
+                        <a:srgbClr val="000000">
+                          <a:alpha val="0"/>
+                        </a:srgbClr>
+                      </a:solidFill>
+                      <a:prstDash val="solid"/>
+                      <a:round/>
+                      <a:headEnd type="none" w="sm" len="sm"/>
+                      <a:tailEnd type="none" w="sm" len="sm"/>
+                    </a:lnB>
+                    <a:solidFill>
+                      <a:srgbClr val="F4F3EF"/>
+                    </a:solidFill>
+                  </a:tcPr>
+                </a:tc>
+                <a:extLst>
+                  <a:ext uri="{0D108BD9-81ED-4DB2-BD59-A6C34878D82A}">
+                    <a16:rowId xmlns:a16="http://schemas.microsoft.com/office/drawing/2014/main" val="10005"/>
+                  </a:ext>
+                </a:extLst>
+              </a:tr>
+              <a:tr h="446100">
+                <a:tc>
+                  <a:txBody>
+                    <a:bodyPr/>
+                    <a:lstStyle/>
+                    <a:p>
+                      <a:pPr marL="0" marR="0" lvl="0" indent="0" algn="l" rtl="0">
+                        <a:spcBef>
+                          <a:spcPts val="0"/>
+                        </a:spcBef>
+                        <a:spcAft>
+                          <a:spcPts val="0"/>
+                        </a:spcAft>
+                        <a:buNone/>
+                        <a:defRPr sz="1000">
+                          <a:solidFill>
+                            <a:srgbClr val="3E444A"/>
+                          </a:solidFill>
+                          <a:latin typeface="Calibri"/>
+                        </a:defRPr>
+                      </a:pPr>
+                      <a:r>
+                        <a:rPr lang="en-US" sz="1350" b="1" dirty="0"/>
+                        <a:t>G13</a:t>
+                      </a:r>
+                      <a:endParaRPr sz="1350" b="1" dirty="0"/>
+                    </a:p>
+                  </a:txBody>
+                  <a:tcPr marL="63500" marR="63500" marT="25400" marB="25400" anchor="ctr">
+                    <a:lnL w="9525" cap="flat" cmpd="sng">
+                      <a:solidFill>
+                        <a:srgbClr val="000000">
+                          <a:alpha val="0"/>
+                        </a:srgbClr>
+                      </a:solidFill>
+                      <a:prstDash val="solid"/>
+                      <a:round/>
+                      <a:headEnd type="none" w="sm" len="sm"/>
+                      <a:tailEnd type="none" w="sm" len="sm"/>
+                    </a:lnL>
+                    <a:lnR w="9525" cap="flat" cmpd="sng" algn="ctr">
                       <a:solidFill>
                         <a:srgbClr val="000000">
                           <a:alpha val="0"/>
@@ -19260,22 +19558,116 @@
                         </a:defRPr>
                       </a:pPr>
                       <a:r>
-                        <a:rPr lang="en-US" sz="1350" b="0" i="0" u="none" strike="noStrike" cap="none" dirty="0">
+                        <a:rPr lang="en-IN" sz="1350" b="0" i="0" u="none" strike="noStrike" cap="none" spc="0" dirty="0">
+                          <a:solidFill>
+                            <a:schemeClr val="tx1"/>
+                          </a:solidFill>
+                          <a:latin typeface="Calibri"/>
+                          <a:ea typeface="Arial"/>
+                          <a:cs typeface="Arial"/>
+                          <a:sym typeface="Arial"/>
+                        </a:rPr>
+                        <a:t>Device &amp; sensor evidence unchanged while waiting for user confirmation</a:t>
+                      </a:r>
+                      <a:endParaRPr sz="1350" b="0" dirty="0">
+                        <a:solidFill>
+                          <a:schemeClr val="tx1"/>
+                        </a:solidFill>
+                      </a:endParaRPr>
+                    </a:p>
+                  </a:txBody>
+                  <a:tcPr marL="63500" marR="63500" marT="25400" marB="25400" anchor="ctr">
+                    <a:lnL w="9525" cap="flat" cmpd="sng" algn="ctr">
+                      <a:solidFill>
+                        <a:srgbClr val="000000">
+                          <a:alpha val="0"/>
+                        </a:srgbClr>
+                      </a:solidFill>
+                      <a:prstDash val="solid"/>
+                      <a:round/>
+                      <a:headEnd type="none" w="sm" len="sm"/>
+                      <a:tailEnd type="none" w="sm" len="sm"/>
+                    </a:lnL>
+                    <a:lnR w="9525" cap="flat" cmpd="sng" algn="ctr">
+                      <a:solidFill>
+                        <a:srgbClr val="000000">
+                          <a:alpha val="0"/>
+                        </a:srgbClr>
+                      </a:solidFill>
+                      <a:prstDash val="solid"/>
+                      <a:round/>
+                      <a:headEnd type="none" w="sm" len="sm"/>
+                      <a:tailEnd type="none" w="sm" len="sm"/>
+                    </a:lnR>
+                    <a:lnT w="9525" cap="flat" cmpd="sng">
+                      <a:solidFill>
+                        <a:srgbClr val="000000">
+                          <a:alpha val="0"/>
+                        </a:srgbClr>
+                      </a:solidFill>
+                      <a:prstDash val="solid"/>
+                      <a:round/>
+                      <a:headEnd type="none" w="sm" len="sm"/>
+                      <a:tailEnd type="none" w="sm" len="sm"/>
+                    </a:lnT>
+                    <a:lnB w="9525" cap="flat" cmpd="sng">
+                      <a:solidFill>
+                        <a:srgbClr val="000000">
+                          <a:alpha val="0"/>
+                        </a:srgbClr>
+                      </a:solidFill>
+                      <a:prstDash val="solid"/>
+                      <a:round/>
+                      <a:headEnd type="none" w="sm" len="sm"/>
+                      <a:tailEnd type="none" w="sm" len="sm"/>
+                    </a:lnB>
+                    <a:solidFill>
+                      <a:srgbClr val="F4F3EF"/>
+                    </a:solidFill>
+                  </a:tcPr>
+                </a:tc>
+                <a:tc>
+                  <a:txBody>
+                    <a:bodyPr/>
+                    <a:lstStyle/>
+                    <a:p>
+                      <a:pPr marL="0" marR="0" lvl="0" indent="0" algn="l" rtl="0">
+                        <a:spcBef>
+                          <a:spcPts val="0"/>
+                        </a:spcBef>
+                        <a:spcAft>
+                          <a:spcPts val="0"/>
+                        </a:spcAft>
+                        <a:buNone/>
+                        <a:defRPr sz="1000">
                           <a:solidFill>
                             <a:srgbClr val="3E444A"/>
                           </a:solidFill>
                           <a:latin typeface="Calibri"/>
-                          <a:ea typeface="Calibri"/>
-                          <a:cs typeface="Calibri"/>
-                          <a:sym typeface="Calibri"/>
+                        </a:defRPr>
+                      </a:pPr>
+                      <a:r>
+                        <a:rPr lang="en-IN" sz="1350" b="0" i="0" u="none" strike="noStrike" cap="none" spc="0" dirty="0">
+                          <a:solidFill>
+                            <a:schemeClr val="tx1"/>
+                          </a:solidFill>
+                          <a:effectLst/>
+                          <a:latin typeface="Calibri"/>
+                          <a:ea typeface="Arial"/>
+                          <a:cs typeface="Arial"/>
+                          <a:sym typeface="Arial"/>
                         </a:rPr>
-                        <a:t>Withdraw before wire or hold for correction</a:t>
+                        <a:t>The action is not executed</a:t>
                       </a:r>
-                      <a:endParaRPr dirty="0"/>
+                      <a:endParaRPr sz="1350" b="0" dirty="0">
+                        <a:solidFill>
+                          <a:schemeClr val="tx1"/>
+                        </a:solidFill>
+                      </a:endParaRPr>
                     </a:p>
                   </a:txBody>
                   <a:tcPr marL="63500" marR="63500" marT="25400" marB="25400" anchor="ctr">
-                    <a:lnL w="9525" cap="flat" cmpd="sng">
+                    <a:lnL w="9525" cap="flat" cmpd="sng" algn="ctr">
                       <a:solidFill>
                         <a:srgbClr val="000000">
                           <a:alpha val="0"/>
@@ -19326,7 +19718,7 @@
                 </a:tc>
                 <a:extLst>
                   <a:ext uri="{0D108BD9-81ED-4DB2-BD59-A6C34878D82A}">
-                    <a16:rowId xmlns:a16="http://schemas.microsoft.com/office/drawing/2014/main" val="10005"/>
+                    <a16:rowId xmlns:a16="http://schemas.microsoft.com/office/drawing/2014/main" val="2389119752"/>
                   </a:ext>
                 </a:extLst>
               </a:tr>

</xml_diff>

<commit_message>
docs: Round 2 deck fixes: G13 throughout, SmartThings virtual devices stated, walkthrough matches the final video, relaxed-contract footnote
Claude-Session: https://claude.ai/code/session_01QXwf3GSkk849J2aZsEBb4p
</commit_message>
<xml_diff>
--- a/VITVellore_AICA.pptx
+++ b/VITVellore_AICA.pptx
@@ -11680,7 +11680,7 @@
           <a:p>
             <a:r>
               <a:rPr sz="1300" b="0" dirty="0"/>
-              <a:t>Real devices. Real confirmation. Honest failures.</a:t>
+              <a:t>Real cloud. Real confirmation. Honest failures.</a:t>
             </a:r>
           </a:p>
         </p:txBody>
@@ -11781,7 +11781,7 @@
             <a:pPr lvl="0" algn="just"/>
             <a:r>
               <a:rPr lang="en-IN" sz="1100" dirty="0"/>
-              <a:t>Unifies real multi-category Samsung devices, including smart locks, garage doors, thermostats, wall switches, and washers.</a:t>
+              <a:t>Controls SmartThings cloud virtual devices: a lock, a garage door opener, a thermostat and a switch. The washer and the technician booking are simulated.</a:t>
             </a:r>
           </a:p>
         </p:txBody>
@@ -11882,7 +11882,7 @@
             <a:pPr lvl="0" algn="just"/>
             <a:r>
               <a:rPr lang="en-IN" sz="1200" dirty="0"/>
-              <a:t>Janus enforces a mandatory physical state read-back after every write to verify that the hardware actually moved.</a:t>
+              <a:t>Janus enforces a state read-back after every write to verify that the device reported the change.</a:t>
             </a:r>
           </a:p>
           <a:p>
@@ -11893,7 +11893,7 @@
             <a:pPr lvl="0" algn="just"/>
             <a:r>
               <a:rPr lang="en-IN" sz="1200" dirty="0"/>
-              <a:t>If the physical device does not confirm movement, Janus honestly reports that the command was sent but unverified.</a:t>
+              <a:t>If the device does not confirm the change, Janus honestly reports that the command was sent but unverified.</a:t>
             </a:r>
           </a:p>
           <a:p>
@@ -12124,7 +12124,7 @@
             <a:pPr lvl="0" algn="just"/>
             <a:r>
               <a:rPr lang="en-IN" sz="1200" dirty="0"/>
-              <a:t>An interactive failure drawer lets the jury inject real-world IoT chaos live, including hub drops, dropped confirmations, and concurrent commands.</a:t>
+              <a:t>An interactive failure drawer lets the jury inject faults live: SmartThings outages, dropped confirmations, slow or unavailable models, and outside changes.</a:t>
             </a:r>
           </a:p>
           <a:p>
@@ -12310,13 +12310,13 @@
           <a:p>
             <a:r>
               <a:rPr sz="1200" b="0"/>
-              <a:t>Duration: 1 min 50 s</a:t>
+              <a:t>Duration: 1 min 59 s</a:t>
             </a:r>
           </a:p>
           <a:p>
             <a:r>
               <a:rPr sz="1200" b="0"/>
-              <a:t>Voice: Gemini 3.6 Flash + Silero VAD + Kokoro TTS</a:t>
+              <a:t>Voice: Gemini 3.6 Flash + Parakeet STT + Silero VAD + Kokoro TTS</a:t>
             </a:r>
           </a:p>
           <a:p>
@@ -12366,13 +12366,13 @@
           <a:p>
             <a:r>
               <a:rPr sz="1300" b="1" dirty="0"/>
-              <a:t>Companion App Joins Room</a:t>
+              <a:t>0:00  Correction: the latest value wins</a:t>
             </a:r>
           </a:p>
           <a:p>
             <a:r>
               <a:rPr sz="1200" b="0" dirty="0"/>
-              <a:t>Live device tiles appear (Lock, Garage, AC, Switch, Washer) over WebRTC.</a:t>
+              <a:t>“Set the thermostat to 22… actually, 21.” The 22 had already been confirmed, so the correction sends 21; both are on the ledger.</a:t>
             </a:r>
           </a:p>
           <a:p>
@@ -12381,13 +12381,13 @@
           <a:p>
             <a:r>
               <a:rPr sz="1300" b="1" dirty="0"/>
-              <a:t>Washer Error (4C) Diagnostics</a:t>
+              <a:t>0:27  Camera + interruption</a:t>
             </a:r>
           </a:p>
           <a:p>
             <a:r>
               <a:rPr sz="1200" b="0" dirty="0"/>
-              <a:t>Camera reads 7-segment display. Agent diagnoses water supply error and speaks fix.</a:t>
+              <a:t>Janus reads the 4C code off the washer display, is cut off mid-explanation, and books Friday afternoon once.</a:t>
             </a:r>
           </a:p>
           <a:p>
@@ -12396,67 +12396,43 @@
           <a:p>
             <a:r>
               <a:rPr sz="1300" b="1" dirty="0"/>
-              <a:t>Mid-Speech Correction &amp; G12 Security Gate</a:t>
+              <a:t>1:00  An outside change withdraws an offer</a:t>
             </a:r>
           </a:p>
           <a:p>
             <a:r>
               <a:rPr sz="1200" b="0" dirty="0"/>
-              <a:t>"Set AC to 2</a:t>
+              <a:t>The garage is opened from outside; Janus offers to close it, someone else closes it first, and the offer is withdrawn unsent.</a:t>
             </a:r>
+          </a:p>
+          <a:p>
+            <a:endParaRPr sz="1200" b="0" dirty="0"/>
+          </a:p>
+          <a:p>
             <a:r>
-              <a:rPr lang="en-US" sz="1200" b="0" dirty="0"/>
-              <a:t>2</a:t>
+              <a:rPr sz="1300" b="1" dirty="0"/>
+              <a:t>1:14  Security confirmation (G12)</a:t>
             </a:r>
+          </a:p>
+          <a:p>
             <a:r>
               <a:rPr sz="1200" b="0" dirty="0"/>
-              <a:t>... no, 2</a:t>
+              <a:t>“Unlock the front door” gets “That’s a security action. Shall I…?” It unlocks only after your yes, and says done only after the lock confirms.</a:t>
             </a:r>
+          </a:p>
+          <a:p>
+            <a:endParaRPr sz="1200" b="0" dirty="0"/>
+          </a:p>
+          <a:p>
             <a:r>
-              <a:rPr lang="en-US" sz="1200" b="0" dirty="0"/>
-              <a:t>1</a:t>
+              <a:rPr sz="1300" b="1" dirty="0"/>
+              <a:t>1:37  Recap from the ledger, then failure drills</a:t>
             </a:r>
+          </a:p>
+          <a:p>
             <a:r>
               <a:rPr sz="1200" b="0" dirty="0"/>
-              <a:t>" — 2</a:t>
-            </a:r>
-            <a:r>
-              <a:rPr lang="en-US" sz="1200" b="0" dirty="0"/>
-              <a:t>2</a:t>
-            </a:r>
-            <a:r>
-              <a:rPr sz="1200" b="0" dirty="0"/>
-              <a:t> is cancelled before emit. "Lock door" triggers spoken confirmation.</a:t>
-            </a:r>
-          </a:p>
-          <a:p>
-            <a:endParaRPr sz="1200" b="0" dirty="0"/>
-          </a:p>
-          <a:p>
-            <a:r>
-              <a:rPr sz="1300" b="1" dirty="0"/>
-              <a:t>Live Failure Drill ("Sent is Not Done")</a:t>
-            </a:r>
-          </a:p>
-          <a:p>
-            <a:r>
-              <a:rPr sz="1200" b="0" dirty="0"/>
-              <a:t>Jury injects stuck lock. State never confirms. Agent speaks: "Sent, but couldn't confirm."</a:t>
-            </a:r>
-          </a:p>
-          <a:p>
-            <a:endParaRPr sz="1200" b="0" dirty="0"/>
-          </a:p>
-          <a:p>
-            <a:r>
-              <a:rPr sz="1300" b="1" dirty="0"/>
-              <a:t>Effect Ledger Summary</a:t>
-            </a:r>
-          </a:p>
-          <a:p>
-            <a:r>
-              <a:rPr sz="1200" b="0" dirty="0"/>
-              <a:t>App displays: 2 committed, 1 cancelled before send, 1 unconfirmed, 0 duplicates.</a:t>
+              <a:t>“What did you do?” is answered from the ledger (4 committed, 1 never sent). Then four drills side by side: SmartThings down, never confirms, slow, model down.</a:t>
             </a:r>
           </a:p>
         </p:txBody>
@@ -16090,29 +16066,7 @@
                 <a:ea typeface="Calibri" panose="020F0502020204030204" pitchFamily="34" charset="0"/>
                 <a:cs typeface="Calibri" panose="020F0502020204030204" pitchFamily="34" charset="0"/>
               </a:rPr>
-              <a:t>• </a:t>
-            </a:r>
-            <a:r>
-              <a:rPr lang="en-US" dirty="0" err="1">
-                <a:solidFill>
-                  <a:schemeClr val="bg1"/>
-                </a:solidFill>
-                <a:latin typeface="Calibri" panose="020F0502020204030204" pitchFamily="34" charset="0"/>
-                <a:ea typeface="Calibri" panose="020F0502020204030204" pitchFamily="34" charset="0"/>
-                <a:cs typeface="Calibri" panose="020F0502020204030204" pitchFamily="34" charset="0"/>
-              </a:rPr>
-              <a:t>CommitGate</a:t>
-            </a:r>
-            <a:r>
-              <a:rPr lang="en-US" dirty="0">
-                <a:solidFill>
-                  <a:schemeClr val="bg1"/>
-                </a:solidFill>
-                <a:latin typeface="Calibri" panose="020F0502020204030204" pitchFamily="34" charset="0"/>
-                <a:ea typeface="Calibri" panose="020F0502020204030204" pitchFamily="34" charset="0"/>
-                <a:cs typeface="Calibri" panose="020F0502020204030204" pitchFamily="34" charset="0"/>
-              </a:rPr>
-              <a:t> G1–G12 checks</a:t>
+              <a:t>• CommitGate G1–G13 checks</a:t>
             </a:r>
           </a:p>
           <a:p>
@@ -16151,7 +16105,7 @@
                 <a:ea typeface="Calibri" panose="020F0502020204030204" pitchFamily="34" charset="0"/>
                 <a:cs typeface="Calibri" panose="020F0502020204030204" pitchFamily="34" charset="0"/>
               </a:rPr>
-              <a:t>• G12 spoken confirmation gate</a:t>
+              <a:t>• G12–G13 confirmation + evidence gates</a:t>
             </a:r>
           </a:p>
           <a:p>
@@ -16727,7 +16681,7 @@
           <a:p>
             <a:r>
               <a:rPr sz="1150" b="0"/>
-              <a:t>Run fixed-order sub-phases, update task FSM, check CommitGate G1–G12.</a:t>
+              <a:t>Run fixed-order sub-phases, update task FSM, check CommitGate G1–G13.</a:t>
             </a:r>
           </a:p>
         </p:txBody>
@@ -17526,7 +17480,7 @@
                 <a:ea typeface="Calibri" panose="020F0502020204030204" pitchFamily="34" charset="0"/>
                 <a:cs typeface="Calibri" panose="020F0502020204030204" pitchFamily="34" charset="0"/>
               </a:rPr>
-              <a:t>We hash SHA-256 hashing instead of Python’s hashing, so replays do not occur.</a:t>
+              <a:t>Digests are SHA-256, not Python’s hash(), so replays are byte-identical.</a:t>
             </a:r>
           </a:p>
         </p:txBody>
@@ -17624,11 +17578,7 @@
             </a:pPr>
             <a:r>
               <a:rPr dirty="0" err="1"/>
-              <a:t>CommitGate</a:t>
-            </a:r>
-            <a:r>
-              <a:rPr dirty="0"/>
-              <a:t> (G1-G12) &amp; Pre-Emission Effect Ledger</a:t>
+              <a:t>CommitGate (G1-G13) &amp; Pre-Emission Effect Ledger</a:t>
             </a:r>
           </a:p>
         </p:txBody>
@@ -19567,7 +19517,7 @@
                           <a:cs typeface="Arial"/>
                           <a:sym typeface="Arial"/>
                         </a:rPr>
-                        <a:t>Device &amp; sensor evidence unchanged while waiting for user confirmation</a:t>
+                        <a:t>World unchanged since the confirmation question was asked (watched device state, or what the camera showed)</a:t>
                       </a:r>
                       <a:endParaRPr sz="1350" b="0" dirty="0">
                         <a:solidFill>
@@ -19657,7 +19607,7 @@
                           <a:cs typeface="Arial"/>
                           <a:sym typeface="Arial"/>
                         </a:rPr>
-                        <a:t>The action is not executed</a:t>
+                        <a:t>Withdraw unsent; tell the user what changed and ask again</a:t>
                       </a:r>
                       <a:endParaRPr sz="1350" b="0" dirty="0">
                         <a:solidFill>
@@ -19814,7 +19764,7 @@
               </a:defRPr>
             </a:pPr>
             <a:r>
-              <a:t>CommitGate (G1-G12) Rule Enforcement Matrix</a:t>
+              <a:t>CommitGate (G1-G13) Rule Enforcement Matrix</a:t>
             </a:r>
             <a:endParaRPr dirty="0"/>
           </a:p>
@@ -20018,6 +19968,39 @@
           </a:prstGeom>
         </p:spPr>
       </p:pic>
+      <p:sp>
+        <p:nvSpPr>
+          <p:cNvPr id="285" name="TextBox 284"/>
+          <p:cNvSpPr txBox="1"/>
+          <p:nvPr/>
+        </p:nvSpPr>
+        <p:spPr>
+          <a:xfrm>
+            <a:off x="1945105" y="6366260"/>
+            <a:ext cx="8301789" cy="330000"/>
+          </a:xfrm>
+          <a:prstGeom prst="rect">
+            <a:avLst/>
+          </a:prstGeom>
+          <a:noFill/>
+        </p:spPr>
+        <p:txBody>
+          <a:bodyPr wrap="square">
+            <a:spAutoFit/>
+          </a:bodyPr>
+          <a:lstStyle/>
+          <a:p>
+            <a:r>
+              <a:rPr sz="1000">
+                <a:solidFill>
+                  <a:srgbClr val="5A646E"/>
+                </a:solidFill>
+              </a:rPr>
+              <a:t>Reported runs use the relaxed housing tool contract (documented in the README, switchable): 82/100 judged, 79/100 exact match; 74/100 with the published tool definitions. Judge: gpt-4o.</a:t>
+            </a:r>
+          </a:p>
+        </p:txBody>
+      </p:sp>
     </p:spTree>
   </p:cSld>
   <p:clrMapOvr>

</xml_diff>

<commit_message>
docs: final Round 2 deck (the play button links the demo video)
Claude-Session: https://claude.ai/code/session_01QXwf3GSkk849J2aZsEBb4p
</commit_message>
<xml_diff>
--- a/VITVellore_AICA.pptx
+++ b/VITVellore_AICA.pptx
@@ -12275,7 +12275,7 @@
         <p:spPr>
           <a:xfrm>
             <a:off x="7360920" y="1691640"/>
-            <a:ext cx="3931920" cy="3931920"/>
+            <a:ext cx="3931920" cy="1523494"/>
           </a:xfrm>
           <a:prstGeom prst="rect">
             <a:avLst/>
@@ -12300,34 +12300,69 @@
               </a:defRPr>
             </a:pPr>
             <a:r>
-              <a:rPr sz="1400" b="1"/>
+              <a:rPr sz="1400" b="1" dirty="0">
+                <a:hlinkClick r:id="rId2"/>
+              </a:rPr>
               <a:t>[ CLICK TO PLAY DEMO VIDEO ]</a:t>
             </a:r>
-          </a:p>
-          <a:p>
-            <a:endParaRPr sz="1400" b="1"/>
+            <a:endParaRPr sz="1400" b="1" dirty="0"/>
+          </a:p>
+          <a:p>
+            <a:endParaRPr sz="1400" b="1" dirty="0"/>
           </a:p>
           <a:p>
             <a:r>
-              <a:rPr sz="1200" b="0"/>
+              <a:rPr sz="1200" b="0" dirty="0">
+                <a:solidFill>
+                  <a:schemeClr val="bg1"/>
+                </a:solidFill>
+              </a:rPr>
               <a:t>Duration: 1 min 59 s</a:t>
             </a:r>
           </a:p>
           <a:p>
             <a:r>
-              <a:rPr sz="1200" b="0"/>
-              <a:t>Voice: Gemini 3.6 Flash + Parakeet STT + Silero VAD + Kokoro TTS</a:t>
+              <a:rPr sz="1200" b="0" dirty="0">
+                <a:solidFill>
+                  <a:schemeClr val="bg1"/>
+                </a:solidFill>
+              </a:rPr>
+              <a:t>Voice: Gemini 3.6 Flash + Parakeet STT + </a:t>
             </a:r>
-          </a:p>
-          <a:p>
             <a:r>
-              <a:rPr sz="1200" b="0"/>
+              <a:rPr sz="1200" b="0" dirty="0" err="1">
+                <a:solidFill>
+                  <a:schemeClr val="bg1"/>
+                </a:solidFill>
+              </a:rPr>
+              <a:t>Silero</a:t>
+            </a:r>
+            <a:r>
+              <a:rPr sz="1200" b="0" dirty="0">
+                <a:solidFill>
+                  <a:schemeClr val="bg1"/>
+                </a:solidFill>
+              </a:rPr>
+              <a:t> VAD + Kokoro TTS</a:t>
+            </a:r>
+          </a:p>
+          <a:p>
+            <a:r>
+              <a:rPr sz="1200" b="0" dirty="0">
+                <a:solidFill>
+                  <a:schemeClr val="bg1"/>
+                </a:solidFill>
+              </a:rPr>
               <a:t>SmartThings: Real Cloud API — live virtual devices</a:t>
             </a:r>
           </a:p>
           <a:p>
             <a:r>
-              <a:rPr sz="1200" b="0"/>
+              <a:rPr sz="1200" b="0" dirty="0">
+                <a:solidFill>
+                  <a:schemeClr val="bg1"/>
+                </a:solidFill>
+              </a:rPr>
               <a:t>App: Android 14 companion (Hermes, physical device)</a:t>
             </a:r>
           </a:p>

</xml_diff>